<commit_message>
Add GPR technical report for user review
</commit_message>
<xml_diff>
--- a/探地雷达_背景抑制与AGC改进_汇报_2026-03-02.pptx
+++ b/探地雷达_背景抑制与AGC改进_汇报_2026-03-02.pptx
@@ -4158,27 +4158,18 @@
           </a:bodyPr>
           <a:lstStyle/>
           <a:p>
-            <a:pPr>
-              <a:defRPr sz="2000"/>
-            </a:pPr>
-            <a:r>
-              <a:t>SNR提升需基线定义；A8-NEW-1含NaN trace需剔除/填补。</a:t>
-            </a:r>
-          </a:p>
-          <a:p>
-            <a:pPr>
-              <a:defRPr sz="2000"/>
-            </a:pPr>
-            <a:r>
-              <a:t>SVD秩=1为经验值，需目标保持性验证。</a:t>
-            </a:r>
-          </a:p>
-          <a:p>
-            <a:pPr>
-              <a:defRPr sz="2000"/>
-            </a:pPr>
-            <a:r>
-              <a:t>下一步：完善消融（无AGC/不同窗/不同背景抑制）+ 指标表。</a:t>
+            <a:r>
+              <a:t>默认指标（A8-NEW-1, 统一色标）：基线SNR≈12 dB；SVD背景抑制与基线接近(SSIM≈0.995)；</a:t>
+            </a:r>
+          </a:p>
+          <a:p>
+            <a:r>
+              <a:t>AGC改进在当前窗口定义下SNR/对比度下降(SSIM≈0.21)，需进一步调参验证目标保持性。</a:t>
+            </a:r>
+          </a:p>
+          <a:p>
+            <a:r>
+              <a:t>A8-NEW-1含NaN trace需剔除/填补；后续补充无AGC/不同窗/不同秩的消融对照。</a:t>
             </a:r>
           </a:p>
         </p:txBody>
@@ -4470,7 +4461,7 @@
                     <a:lstStyle/>
                     <a:p>
                       <a:r>
-                        <a:t>SNR提升</a:t>
+                        <a:t>SNR(dB)</a:t>
                       </a:r>
                     </a:p>
                   </a:txBody>
@@ -4494,7 +4485,7 @@
                     <a:lstStyle/>
                     <a:p>
                       <a:r>
-                        <a:t>结构保真</a:t>
+                        <a:t>结构保真(SSIM)</a:t>
                       </a:r>
                     </a:p>
                   </a:txBody>
@@ -4506,7 +4497,7 @@
                     <a:lstStyle/>
                     <a:p>
                       <a:r>
-                        <a:t>运行耗时</a:t>
+                        <a:t>运行耗时(s)</a:t>
                       </a:r>
                     </a:p>
                   </a:txBody>
@@ -4532,7 +4523,7 @@
                     <a:lstStyle/>
                     <a:p>
                       <a:r>
-                        <a:t>占位(待补充)</a:t>
+                        <a:t>11.97</a:t>
                       </a:r>
                     </a:p>
                   </a:txBody>
@@ -4544,7 +4535,7 @@
                     <a:lstStyle/>
                     <a:p>
                       <a:r>
-                        <a:t>占位(待补充)</a:t>
+                        <a:t>4.26</a:t>
                       </a:r>
                     </a:p>
                   </a:txBody>
@@ -4556,7 +4547,7 @@
                     <a:lstStyle/>
                     <a:p>
                       <a:r>
-                        <a:t>占位(待补充)</a:t>
+                        <a:t>1.000</a:t>
                       </a:r>
                     </a:p>
                   </a:txBody>
@@ -4568,7 +4559,7 @@
                     <a:lstStyle/>
                     <a:p>
                       <a:r>
-                        <a:t>占位(待补充)</a:t>
+                        <a:t>1.16</a:t>
                       </a:r>
                     </a:p>
                   </a:txBody>
@@ -4594,7 +4585,7 @@
                     <a:lstStyle/>
                     <a:p>
                       <a:r>
-                        <a:t>占位(待补充)</a:t>
+                        <a:t>11.64</a:t>
                       </a:r>
                     </a:p>
                   </a:txBody>
@@ -4606,7 +4597,7 @@
                     <a:lstStyle/>
                     <a:p>
                       <a:r>
-                        <a:t>占位(待补充)</a:t>
+                        <a:t>4.04</a:t>
                       </a:r>
                     </a:p>
                   </a:txBody>
@@ -4618,7 +4609,7 @@
                     <a:lstStyle/>
                     <a:p>
                       <a:r>
-                        <a:t>占位(待补充)</a:t>
+                        <a:t>0.995</a:t>
                       </a:r>
                     </a:p>
                   </a:txBody>
@@ -4630,7 +4621,7 @@
                     <a:lstStyle/>
                     <a:p>
                       <a:r>
-                        <a:t>占位(待补充)</a:t>
+                        <a:t>0.65</a:t>
                       </a:r>
                     </a:p>
                   </a:txBody>
@@ -4656,7 +4647,7 @@
                     <a:lstStyle/>
                     <a:p>
                       <a:r>
-                        <a:t>占位(待补充)</a:t>
+                        <a:t>8.33</a:t>
                       </a:r>
                     </a:p>
                   </a:txBody>
@@ -4668,7 +4659,7 @@
                     <a:lstStyle/>
                     <a:p>
                       <a:r>
-                        <a:t>占位(待补充)</a:t>
+                        <a:t>2.65</a:t>
                       </a:r>
                     </a:p>
                   </a:txBody>
@@ -4680,7 +4671,7 @@
                     <a:lstStyle/>
                     <a:p>
                       <a:r>
-                        <a:t>占位(待补充)</a:t>
+                        <a:t>0.210</a:t>
                       </a:r>
                     </a:p>
                   </a:txBody>
@@ -4692,7 +4683,7 @@
                     <a:lstStyle/>
                     <a:p>
                       <a:r>
-                        <a:t>占位(待补充)</a:t>
+                        <a:t>0.71</a:t>
                       </a:r>
                     </a:p>
                   </a:txBody>
@@ -4725,11 +4716,8 @@
           </a:bodyPr>
           <a:lstStyle/>
           <a:p>
-            <a:pPr>
-              <a:defRPr sz="1200"/>
-            </a:pPr>
-            <a:r>
-              <a:t>注：指标数值待补充或引用已有实验记录来源。</a:t>
+            <a:r>
+              <a:t>注：统一色标输出；目标窗/背景窗为基线图中RMS最大/最小区域(40×10)，在y=100~700内搜索。SNR=目标窗RMS/噪声窗RMS(dB)。</a:t>
             </a:r>
           </a:p>
         </p:txBody>

</xml_diff>